<commit_message>
finalize code-integrated defense package
</commit_message>
<xml_diff>
--- a/final_defense_package_2026-04-08/02_presentation/osag_defense_deck_en_final.pptx
+++ b/final_defense_package_2026-04-08/02_presentation/osag_defense_deck_en_final.pptx
@@ -29,6 +29,10 @@
     <p:sldId id="277" r:id="rId28"/>
     <p:sldId id="278" r:id="rId29"/>
     <p:sldId id="279" r:id="rId30"/>
+    <p:sldId id="280" r:id="rId31"/>
+    <p:sldId id="281" r:id="rId32"/>
+    <p:sldId id="282" r:id="rId33"/>
+    <p:sldId id="283" r:id="rId34"/>
   </p:sldIdLst>
   <p:sldSz cx="12191999" cy="6858000" type="screen4x3"/>
   <p:notesSz cx="6858000" cy="9144000"/>
@@ -3786,6 +3790,174 @@
       <p:pic>
         <p:nvPicPr>
           <p:cNvPr id="2" name="Picture 1" descr="slide_24.png"/>
+          <p:cNvPicPr>
+            <a:picLocks noChangeAspect="1"/>
+          </p:cNvPicPr>
+          <p:nvPr/>
+        </p:nvPicPr>
+        <p:blipFill>
+          <a:blip r:embed="rId2"/>
+          <a:stretch>
+            <a:fillRect/>
+          </a:stretch>
+        </p:blipFill>
+        <p:spPr>
+          <a:xfrm>
+            <a:off x="0" y="0"/>
+            <a:ext cx="12191999" cy="6858000"/>
+          </a:xfrm>
+          <a:prstGeom prst="rect">
+            <a:avLst/>
+          </a:prstGeom>
+        </p:spPr>
+      </p:pic>
+    </p:spTree>
+  </p:cSld>
+  <p:clrMapOvr>
+    <a:masterClrMapping/>
+  </p:clrMapOvr>
+</p:sld>
+</file>
+
+<file path=ppt/slides/slide25.xml><?xml version="1.0" encoding="utf-8"?>
+<p:sld xmlns:a="http://schemas.openxmlformats.org/drawingml/2006/main" xmlns:p="http://schemas.openxmlformats.org/presentationml/2006/main" xmlns:r="http://schemas.openxmlformats.org/officeDocument/2006/relationships">
+  <p:cSld>
+    <p:spTree>
+      <p:nvGrpSpPr>
+        <p:cNvPr id="1" name=""/>
+        <p:cNvGrpSpPr/>
+        <p:nvPr/>
+      </p:nvGrpSpPr>
+      <p:grpSpPr/>
+      <p:pic>
+        <p:nvPicPr>
+          <p:cNvPr id="2" name="Picture 1" descr="slide_25.png"/>
+          <p:cNvPicPr>
+            <a:picLocks noChangeAspect="1"/>
+          </p:cNvPicPr>
+          <p:nvPr/>
+        </p:nvPicPr>
+        <p:blipFill>
+          <a:blip r:embed="rId2"/>
+          <a:stretch>
+            <a:fillRect/>
+          </a:stretch>
+        </p:blipFill>
+        <p:spPr>
+          <a:xfrm>
+            <a:off x="0" y="0"/>
+            <a:ext cx="12191999" cy="6858000"/>
+          </a:xfrm>
+          <a:prstGeom prst="rect">
+            <a:avLst/>
+          </a:prstGeom>
+        </p:spPr>
+      </p:pic>
+    </p:spTree>
+  </p:cSld>
+  <p:clrMapOvr>
+    <a:masterClrMapping/>
+  </p:clrMapOvr>
+</p:sld>
+</file>
+
+<file path=ppt/slides/slide26.xml><?xml version="1.0" encoding="utf-8"?>
+<p:sld xmlns:a="http://schemas.openxmlformats.org/drawingml/2006/main" xmlns:p="http://schemas.openxmlformats.org/presentationml/2006/main" xmlns:r="http://schemas.openxmlformats.org/officeDocument/2006/relationships">
+  <p:cSld>
+    <p:spTree>
+      <p:nvGrpSpPr>
+        <p:cNvPr id="1" name=""/>
+        <p:cNvGrpSpPr/>
+        <p:nvPr/>
+      </p:nvGrpSpPr>
+      <p:grpSpPr/>
+      <p:pic>
+        <p:nvPicPr>
+          <p:cNvPr id="2" name="Picture 1" descr="slide_26.png"/>
+          <p:cNvPicPr>
+            <a:picLocks noChangeAspect="1"/>
+          </p:cNvPicPr>
+          <p:nvPr/>
+        </p:nvPicPr>
+        <p:blipFill>
+          <a:blip r:embed="rId2"/>
+          <a:stretch>
+            <a:fillRect/>
+          </a:stretch>
+        </p:blipFill>
+        <p:spPr>
+          <a:xfrm>
+            <a:off x="0" y="0"/>
+            <a:ext cx="12191999" cy="6858000"/>
+          </a:xfrm>
+          <a:prstGeom prst="rect">
+            <a:avLst/>
+          </a:prstGeom>
+        </p:spPr>
+      </p:pic>
+    </p:spTree>
+  </p:cSld>
+  <p:clrMapOvr>
+    <a:masterClrMapping/>
+  </p:clrMapOvr>
+</p:sld>
+</file>
+
+<file path=ppt/slides/slide27.xml><?xml version="1.0" encoding="utf-8"?>
+<p:sld xmlns:a="http://schemas.openxmlformats.org/drawingml/2006/main" xmlns:p="http://schemas.openxmlformats.org/presentationml/2006/main" xmlns:r="http://schemas.openxmlformats.org/officeDocument/2006/relationships">
+  <p:cSld>
+    <p:spTree>
+      <p:nvGrpSpPr>
+        <p:cNvPr id="1" name=""/>
+        <p:cNvGrpSpPr/>
+        <p:nvPr/>
+      </p:nvGrpSpPr>
+      <p:grpSpPr/>
+      <p:pic>
+        <p:nvPicPr>
+          <p:cNvPr id="2" name="Picture 1" descr="slide_27.png"/>
+          <p:cNvPicPr>
+            <a:picLocks noChangeAspect="1"/>
+          </p:cNvPicPr>
+          <p:nvPr/>
+        </p:nvPicPr>
+        <p:blipFill>
+          <a:blip r:embed="rId2"/>
+          <a:stretch>
+            <a:fillRect/>
+          </a:stretch>
+        </p:blipFill>
+        <p:spPr>
+          <a:xfrm>
+            <a:off x="0" y="0"/>
+            <a:ext cx="12191999" cy="6858000"/>
+          </a:xfrm>
+          <a:prstGeom prst="rect">
+            <a:avLst/>
+          </a:prstGeom>
+        </p:spPr>
+      </p:pic>
+    </p:spTree>
+  </p:cSld>
+  <p:clrMapOvr>
+    <a:masterClrMapping/>
+  </p:clrMapOvr>
+</p:sld>
+</file>
+
+<file path=ppt/slides/slide28.xml><?xml version="1.0" encoding="utf-8"?>
+<p:sld xmlns:a="http://schemas.openxmlformats.org/drawingml/2006/main" xmlns:p="http://schemas.openxmlformats.org/presentationml/2006/main" xmlns:r="http://schemas.openxmlformats.org/officeDocument/2006/relationships">
+  <p:cSld>
+    <p:spTree>
+      <p:nvGrpSpPr>
+        <p:cNvPr id="1" name=""/>
+        <p:cNvGrpSpPr/>
+        <p:nvPr/>
+      </p:nvGrpSpPr>
+      <p:grpSpPr/>
+      <p:pic>
+        <p:nvPicPr>
+          <p:cNvPr id="2" name="Picture 1" descr="slide_28.png"/>
           <p:cNvPicPr>
             <a:picLocks noChangeAspect="1"/>
           </p:cNvPicPr>

</xml_diff>